<commit_message>
Section 2 is done
</commit_message>
<xml_diff>
--- a/images/images.pptx
+++ b/images/images.pptx
@@ -8,6 +8,7 @@
     <p:sldId id="257" r:id="rId2"/>
     <p:sldId id="258" r:id="rId3"/>
     <p:sldId id="259" r:id="rId4"/>
+    <p:sldId id="260" r:id="rId5"/>
   </p:sldIdLst>
   <p:sldSz cx="12192000" cy="6858000"/>
   <p:notesSz cx="6858000" cy="9144000"/>
@@ -112,7 +113,7 @@
 <file path=ppt/revisionInfo.xml><?xml version="1.0" encoding="utf-8"?>
 <p1510:revInfo xmlns:a="http://schemas.openxmlformats.org/drawingml/2006/main" xmlns:r="http://schemas.openxmlformats.org/officeDocument/2006/relationships" xmlns:p1510="http://schemas.microsoft.com/office/powerpoint/2015/10/main">
   <p1510:revLst>
-    <p1510:client id="{29906621-E66D-4CB3-9CBA-39DF9C321F91}" v="24" dt="2026-08-11T18:53:59.712"/>
+    <p1510:client id="{29906621-E66D-4CB3-9CBA-39DF9C321F91}" v="29" dt="2026-08-11T21:22:15.100"/>
   </p1510:revLst>
 </p1510:revInfo>
 </file>
@@ -122,7 +123,7 @@
   <pc:docChgLst>
     <pc:chgData name="José Moreira" userId="89a7a41d-884e-43a8-997a-1b16820e3dfb" providerId="ADAL" clId="{DC538B31-CBDE-4F8B-A416-53AEEC09C1DA}"/>
     <pc:docChg chg="undo custSel addSld modSld">
-      <pc:chgData name="José Moreira" userId="89a7a41d-884e-43a8-997a-1b16820e3dfb" providerId="ADAL" clId="{DC538B31-CBDE-4F8B-A416-53AEEC09C1DA}" dt="2026-08-11T18:55:19.644" v="485" actId="1036"/>
+      <pc:chgData name="José Moreira" userId="89a7a41d-884e-43a8-997a-1b16820e3dfb" providerId="ADAL" clId="{DC538B31-CBDE-4F8B-A416-53AEEC09C1DA}" dt="2026-08-11T21:22:15.100" v="629" actId="164"/>
       <pc:docMkLst>
         <pc:docMk/>
       </pc:docMkLst>
@@ -489,6 +490,173 @@
             <pc:docMk/>
             <pc:sldMk cId="1544498562" sldId="259"/>
             <ac:cxnSpMk id="31" creationId="{93576BBE-5B04-F3DB-9189-D15264F918F3}"/>
+          </ac:cxnSpMkLst>
+        </pc:cxnChg>
+      </pc:sldChg>
+      <pc:sldChg chg="addSp delSp modSp new mod setBg">
+        <pc:chgData name="José Moreira" userId="89a7a41d-884e-43a8-997a-1b16820e3dfb" providerId="ADAL" clId="{DC538B31-CBDE-4F8B-A416-53AEEC09C1DA}" dt="2026-08-11T21:22:15.100" v="629" actId="164"/>
+        <pc:sldMkLst>
+          <pc:docMk/>
+          <pc:sldMk cId="1676960890" sldId="260"/>
+        </pc:sldMkLst>
+        <pc:spChg chg="add mod">
+          <ac:chgData name="José Moreira" userId="89a7a41d-884e-43a8-997a-1b16820e3dfb" providerId="ADAL" clId="{DC538B31-CBDE-4F8B-A416-53AEEC09C1DA}" dt="2026-08-11T21:22:15.100" v="629" actId="164"/>
+          <ac:spMkLst>
+            <pc:docMk/>
+            <pc:sldMk cId="1676960890" sldId="260"/>
+            <ac:spMk id="4" creationId="{BD4507A6-3487-563C-A391-EABB3267B46D}"/>
+          </ac:spMkLst>
+        </pc:spChg>
+        <pc:spChg chg="add mod ord">
+          <ac:chgData name="José Moreira" userId="89a7a41d-884e-43a8-997a-1b16820e3dfb" providerId="ADAL" clId="{DC538B31-CBDE-4F8B-A416-53AEEC09C1DA}" dt="2026-08-11T21:22:15.100" v="629" actId="164"/>
+          <ac:spMkLst>
+            <pc:docMk/>
+            <pc:sldMk cId="1676960890" sldId="260"/>
+            <ac:spMk id="5" creationId="{6C1DB74E-DB71-7FA3-2F04-E45DA5FB4703}"/>
+          </ac:spMkLst>
+        </pc:spChg>
+        <pc:spChg chg="add del">
+          <ac:chgData name="José Moreira" userId="89a7a41d-884e-43a8-997a-1b16820e3dfb" providerId="ADAL" clId="{DC538B31-CBDE-4F8B-A416-53AEEC09C1DA}" dt="2026-08-11T20:58:36.652" v="494" actId="26606"/>
+          <ac:spMkLst>
+            <pc:docMk/>
+            <pc:sldMk cId="1676960890" sldId="260"/>
+            <ac:spMk id="8" creationId="{5F9CFCE6-877F-4858-B8BD-2C52CA8AFBC4}"/>
+          </ac:spMkLst>
+        </pc:spChg>
+        <pc:spChg chg="add del">
+          <ac:chgData name="José Moreira" userId="89a7a41d-884e-43a8-997a-1b16820e3dfb" providerId="ADAL" clId="{DC538B31-CBDE-4F8B-A416-53AEEC09C1DA}" dt="2026-08-11T20:58:36.652" v="494" actId="26606"/>
+          <ac:spMkLst>
+            <pc:docMk/>
+            <pc:sldMk cId="1676960890" sldId="260"/>
+            <ac:spMk id="10" creationId="{8213F8A0-12AE-4514-8372-0DD766EC28EE}"/>
+          </ac:spMkLst>
+        </pc:spChg>
+        <pc:spChg chg="add del">
+          <ac:chgData name="José Moreira" userId="89a7a41d-884e-43a8-997a-1b16820e3dfb" providerId="ADAL" clId="{DC538B31-CBDE-4F8B-A416-53AEEC09C1DA}" dt="2026-08-11T20:58:36.652" v="494" actId="26606"/>
+          <ac:spMkLst>
+            <pc:docMk/>
+            <pc:sldMk cId="1676960890" sldId="260"/>
+            <ac:spMk id="12" creationId="{9EFF17D4-9A8C-4CE5-B096-D8CCD4400437}"/>
+          </ac:spMkLst>
+        </pc:spChg>
+        <pc:spChg chg="add del">
+          <ac:chgData name="José Moreira" userId="89a7a41d-884e-43a8-997a-1b16820e3dfb" providerId="ADAL" clId="{DC538B31-CBDE-4F8B-A416-53AEEC09C1DA}" dt="2026-08-11T20:58:39.232" v="496" actId="26606"/>
+          <ac:spMkLst>
+            <pc:docMk/>
+            <pc:sldMk cId="1676960890" sldId="260"/>
+            <ac:spMk id="15" creationId="{69D184B2-2226-4E31-BCCB-444330767440}"/>
+          </ac:spMkLst>
+        </pc:spChg>
+        <pc:spChg chg="add del">
+          <ac:chgData name="José Moreira" userId="89a7a41d-884e-43a8-997a-1b16820e3dfb" providerId="ADAL" clId="{DC538B31-CBDE-4F8B-A416-53AEEC09C1DA}" dt="2026-08-11T20:58:39.232" v="496" actId="26606"/>
+          <ac:spMkLst>
+            <pc:docMk/>
+            <pc:sldMk cId="1676960890" sldId="260"/>
+            <ac:spMk id="16" creationId="{1AC4D4E3-486A-464A-8EC8-D44881097267}"/>
+          </ac:spMkLst>
+        </pc:spChg>
+        <pc:spChg chg="add del">
+          <ac:chgData name="José Moreira" userId="89a7a41d-884e-43a8-997a-1b16820e3dfb" providerId="ADAL" clId="{DC538B31-CBDE-4F8B-A416-53AEEC09C1DA}" dt="2026-08-11T20:58:39.232" v="496" actId="26606"/>
+          <ac:spMkLst>
+            <pc:docMk/>
+            <pc:sldMk cId="1676960890" sldId="260"/>
+            <ac:spMk id="17" creationId="{864DE13E-58EB-4475-B79C-0D4FC651239B}"/>
+          </ac:spMkLst>
+        </pc:spChg>
+        <pc:spChg chg="add mod ord">
+          <ac:chgData name="José Moreira" userId="89a7a41d-884e-43a8-997a-1b16820e3dfb" providerId="ADAL" clId="{DC538B31-CBDE-4F8B-A416-53AEEC09C1DA}" dt="2026-08-11T21:22:15.100" v="629" actId="164"/>
+          <ac:spMkLst>
+            <pc:docMk/>
+            <pc:sldMk cId="1676960890" sldId="260"/>
+            <ac:spMk id="18" creationId="{1FF552BC-4FCB-1569-4B9A-401E2DDA2EA4}"/>
+          </ac:spMkLst>
+        </pc:spChg>
+        <pc:grpChg chg="add mod">
+          <ac:chgData name="José Moreira" userId="89a7a41d-884e-43a8-997a-1b16820e3dfb" providerId="ADAL" clId="{DC538B31-CBDE-4F8B-A416-53AEEC09C1DA}" dt="2026-08-11T21:22:15.100" v="629" actId="164"/>
+          <ac:grpSpMkLst>
+            <pc:docMk/>
+            <pc:sldMk cId="1676960890" sldId="260"/>
+            <ac:grpSpMk id="13" creationId="{7A7AAF82-7AAB-15FC-55E6-C9AFC38CAA5C}"/>
+          </ac:grpSpMkLst>
+        </pc:grpChg>
+        <pc:grpChg chg="add mod">
+          <ac:chgData name="José Moreira" userId="89a7a41d-884e-43a8-997a-1b16820e3dfb" providerId="ADAL" clId="{DC538B31-CBDE-4F8B-A416-53AEEC09C1DA}" dt="2026-08-11T21:22:15.100" v="629" actId="164"/>
+          <ac:grpSpMkLst>
+            <pc:docMk/>
+            <pc:sldMk cId="1676960890" sldId="260"/>
+            <ac:grpSpMk id="29" creationId="{6BB0E808-173F-953E-D593-8AFA7D59210E}"/>
+          </ac:grpSpMkLst>
+        </pc:grpChg>
+        <pc:picChg chg="add mod ord">
+          <ac:chgData name="José Moreira" userId="89a7a41d-884e-43a8-997a-1b16820e3dfb" providerId="ADAL" clId="{DC538B31-CBDE-4F8B-A416-53AEEC09C1DA}" dt="2026-08-11T21:22:15.100" v="629" actId="164"/>
+          <ac:picMkLst>
+            <pc:docMk/>
+            <pc:sldMk cId="1676960890" sldId="260"/>
+            <ac:picMk id="2" creationId="{A934420F-E748-9D59-40C5-9F8CED62814D}"/>
+          </ac:picMkLst>
+        </pc:picChg>
+        <pc:picChg chg="add mod">
+          <ac:chgData name="José Moreira" userId="89a7a41d-884e-43a8-997a-1b16820e3dfb" providerId="ADAL" clId="{DC538B31-CBDE-4F8B-A416-53AEEC09C1DA}" dt="2026-08-11T21:22:15.100" v="629" actId="164"/>
+          <ac:picMkLst>
+            <pc:docMk/>
+            <pc:sldMk cId="1676960890" sldId="260"/>
+            <ac:picMk id="3" creationId="{FB7D15D4-4E74-25FD-3755-C24BEB1F62EF}"/>
+          </ac:picMkLst>
+        </pc:picChg>
+        <pc:picChg chg="add mod">
+          <ac:chgData name="José Moreira" userId="89a7a41d-884e-43a8-997a-1b16820e3dfb" providerId="ADAL" clId="{DC538B31-CBDE-4F8B-A416-53AEEC09C1DA}" dt="2026-08-11T21:17:06.392" v="593" actId="164"/>
+          <ac:picMkLst>
+            <pc:docMk/>
+            <pc:sldMk cId="1676960890" sldId="260"/>
+            <ac:picMk id="7" creationId="{2C8A9CE9-89E1-533B-B51D-D3B3E86701EB}"/>
+          </ac:picMkLst>
+        </pc:picChg>
+        <pc:picChg chg="add mod">
+          <ac:chgData name="José Moreira" userId="89a7a41d-884e-43a8-997a-1b16820e3dfb" providerId="ADAL" clId="{DC538B31-CBDE-4F8B-A416-53AEEC09C1DA}" dt="2026-08-11T21:17:06.392" v="593" actId="164"/>
+          <ac:picMkLst>
+            <pc:docMk/>
+            <pc:sldMk cId="1676960890" sldId="260"/>
+            <ac:picMk id="9" creationId="{386C9DB5-6D05-617A-2086-9DCE3443FFA4}"/>
+          </ac:picMkLst>
+        </pc:picChg>
+        <pc:picChg chg="add mod">
+          <ac:chgData name="José Moreira" userId="89a7a41d-884e-43a8-997a-1b16820e3dfb" providerId="ADAL" clId="{DC538B31-CBDE-4F8B-A416-53AEEC09C1DA}" dt="2026-08-11T21:17:06.392" v="593" actId="164"/>
+          <ac:picMkLst>
+            <pc:docMk/>
+            <pc:sldMk cId="1676960890" sldId="260"/>
+            <ac:picMk id="11" creationId="{D7858331-DEED-96AC-48E3-7FC9F39D5378}"/>
+          </ac:picMkLst>
+        </pc:picChg>
+        <pc:cxnChg chg="add del">
+          <ac:chgData name="José Moreira" userId="89a7a41d-884e-43a8-997a-1b16820e3dfb" providerId="ADAL" clId="{DC538B31-CBDE-4F8B-A416-53AEEC09C1DA}" dt="2026-08-11T20:58:39.232" v="496" actId="26606"/>
+          <ac:cxnSpMkLst>
+            <pc:docMk/>
+            <pc:sldMk cId="1676960890" sldId="260"/>
+            <ac:cxnSpMk id="14" creationId="{02E9B2EE-76CA-47F3-9977-3F2FCB7FD252}"/>
+          </ac:cxnSpMkLst>
+        </pc:cxnChg>
+        <pc:cxnChg chg="add mod">
+          <ac:chgData name="José Moreira" userId="89a7a41d-884e-43a8-997a-1b16820e3dfb" providerId="ADAL" clId="{DC538B31-CBDE-4F8B-A416-53AEEC09C1DA}" dt="2026-08-11T21:22:15.100" v="629" actId="164"/>
+          <ac:cxnSpMkLst>
+            <pc:docMk/>
+            <pc:sldMk cId="1676960890" sldId="260"/>
+            <ac:cxnSpMk id="20" creationId="{812BA641-CBAD-2743-E8A0-6EEE3B088E9B}"/>
+          </ac:cxnSpMkLst>
+        </pc:cxnChg>
+        <pc:cxnChg chg="add mod">
+          <ac:chgData name="José Moreira" userId="89a7a41d-884e-43a8-997a-1b16820e3dfb" providerId="ADAL" clId="{DC538B31-CBDE-4F8B-A416-53AEEC09C1DA}" dt="2026-08-11T21:22:15.100" v="629" actId="164"/>
+          <ac:cxnSpMkLst>
+            <pc:docMk/>
+            <pc:sldMk cId="1676960890" sldId="260"/>
+            <ac:cxnSpMk id="21" creationId="{DB86E2D3-B267-B5D9-6127-A40440BD15BD}"/>
+          </ac:cxnSpMkLst>
+        </pc:cxnChg>
+        <pc:cxnChg chg="add mod">
+          <ac:chgData name="José Moreira" userId="89a7a41d-884e-43a8-997a-1b16820e3dfb" providerId="ADAL" clId="{DC538B31-CBDE-4F8B-A416-53AEEC09C1DA}" dt="2026-08-11T21:22:15.100" v="629" actId="164"/>
+          <ac:cxnSpMkLst>
+            <pc:docMk/>
+            <pc:sldMk cId="1676960890" sldId="260"/>
+            <ac:cxnSpMk id="24" creationId="{86297FDF-2212-9DD7-B87E-3C9DA0BF2D8E}"/>
           </ac:cxnSpMkLst>
         </pc:cxnChg>
       </pc:sldChg>
@@ -7276,6 +7444,552 @@
 </p:sld>
 </file>
 
+<file path=ppt/slides/slide4.xml><?xml version="1.0" encoding="utf-8"?>
+<p:sld xmlns:a="http://schemas.openxmlformats.org/drawingml/2006/main" xmlns:r="http://schemas.openxmlformats.org/officeDocument/2006/relationships" xmlns:p="http://schemas.openxmlformats.org/presentationml/2006/main">
+  <p:cSld>
+    <p:spTree>
+      <p:nvGrpSpPr>
+        <p:cNvPr id="1" name=""/>
+        <p:cNvGrpSpPr/>
+        <p:nvPr/>
+      </p:nvGrpSpPr>
+      <p:grpSpPr>
+        <a:xfrm>
+          <a:off x="0" y="0"/>
+          <a:ext cx="0" cy="0"/>
+          <a:chOff x="0" y="0"/>
+          <a:chExt cx="0" cy="0"/>
+        </a:xfrm>
+      </p:grpSpPr>
+      <p:grpSp>
+        <p:nvGrpSpPr>
+          <p:cNvPr id="29" name="Agrupar 28">
+            <a:extLst>
+              <a:ext uri="{FF2B5EF4-FFF2-40B4-BE49-F238E27FC236}">
+                <a16:creationId xmlns:a16="http://schemas.microsoft.com/office/drawing/2014/main" id="{6BB0E808-173F-953E-D593-8AFA7D59210E}"/>
+              </a:ext>
+            </a:extLst>
+          </p:cNvPr>
+          <p:cNvGrpSpPr/>
+          <p:nvPr/>
+        </p:nvGrpSpPr>
+        <p:grpSpPr>
+          <a:xfrm>
+            <a:off x="1065984" y="866631"/>
+            <a:ext cx="5319708" cy="6304643"/>
+            <a:chOff x="1065984" y="866631"/>
+            <a:chExt cx="5319708" cy="6304643"/>
+          </a:xfrm>
+        </p:grpSpPr>
+        <p:sp>
+          <p:nvSpPr>
+            <p:cNvPr id="18" name="Trapézio 17">
+              <a:extLst>
+                <a:ext uri="{FF2B5EF4-FFF2-40B4-BE49-F238E27FC236}">
+                  <a16:creationId xmlns:a16="http://schemas.microsoft.com/office/drawing/2014/main" id="{1FF552BC-4FCB-1569-4B9A-401E2DDA2EA4}"/>
+                </a:ext>
+              </a:extLst>
+            </p:cNvPr>
+            <p:cNvSpPr/>
+            <p:nvPr/>
+          </p:nvSpPr>
+          <p:spPr>
+            <a:xfrm>
+              <a:off x="1569493" y="5182007"/>
+              <a:ext cx="4258101" cy="1064525"/>
+            </a:xfrm>
+            <a:prstGeom prst="trapezoid">
+              <a:avLst>
+                <a:gd name="adj" fmla="val 214142"/>
+              </a:avLst>
+            </a:prstGeom>
+            <a:solidFill>
+              <a:schemeClr val="tx2">
+                <a:lumMod val="10000"/>
+                <a:lumOff val="90000"/>
+              </a:schemeClr>
+            </a:solidFill>
+            <a:ln>
+              <a:solidFill>
+                <a:schemeClr val="bg1">
+                  <a:lumMod val="85000"/>
+                </a:schemeClr>
+              </a:solidFill>
+            </a:ln>
+          </p:spPr>
+          <p:style>
+            <a:lnRef idx="2">
+              <a:schemeClr val="accent1">
+                <a:shade val="15000"/>
+              </a:schemeClr>
+            </a:lnRef>
+            <a:fillRef idx="1">
+              <a:schemeClr val="accent1"/>
+            </a:fillRef>
+            <a:effectRef idx="0">
+              <a:schemeClr val="accent1"/>
+            </a:effectRef>
+            <a:fontRef idx="minor">
+              <a:schemeClr val="lt1"/>
+            </a:fontRef>
+          </p:style>
+          <p:txBody>
+            <a:bodyPr rtlCol="0" anchor="ctr"/>
+            <a:lstStyle/>
+            <a:p>
+              <a:pPr algn="ctr"/>
+              <a:endParaRPr lang="en-US"/>
+            </a:p>
+          </p:txBody>
+        </p:sp>
+        <p:sp>
+          <p:nvSpPr>
+            <p:cNvPr id="5" name="Retângulo: Cantos Arredondados 4">
+              <a:extLst>
+                <a:ext uri="{FF2B5EF4-FFF2-40B4-BE49-F238E27FC236}">
+                  <a16:creationId xmlns:a16="http://schemas.microsoft.com/office/drawing/2014/main" id="{6C1DB74E-DB71-7FA3-2F04-E45DA5FB4703}"/>
+                </a:ext>
+              </a:extLst>
+            </p:cNvPr>
+            <p:cNvSpPr/>
+            <p:nvPr/>
+          </p:nvSpPr>
+          <p:spPr>
+            <a:xfrm>
+              <a:off x="2702256" y="4389460"/>
+              <a:ext cx="1978926" cy="887104"/>
+            </a:xfrm>
+            <a:prstGeom prst="roundRect">
+              <a:avLst/>
+            </a:prstGeom>
+            <a:solidFill>
+              <a:schemeClr val="bg1">
+                <a:lumMod val="95000"/>
+              </a:schemeClr>
+            </a:solidFill>
+            <a:ln>
+              <a:solidFill>
+                <a:schemeClr val="bg1">
+                  <a:lumMod val="75000"/>
+                </a:schemeClr>
+              </a:solidFill>
+            </a:ln>
+          </p:spPr>
+          <p:style>
+            <a:lnRef idx="2">
+              <a:schemeClr val="accent1">
+                <a:shade val="15000"/>
+              </a:schemeClr>
+            </a:lnRef>
+            <a:fillRef idx="1">
+              <a:schemeClr val="accent1"/>
+            </a:fillRef>
+            <a:effectRef idx="0">
+              <a:schemeClr val="accent1"/>
+            </a:effectRef>
+            <a:fontRef idx="minor">
+              <a:schemeClr val="lt1"/>
+            </a:fontRef>
+          </p:style>
+          <p:txBody>
+            <a:bodyPr rtlCol="0" anchor="ctr"/>
+            <a:lstStyle/>
+            <a:p>
+              <a:pPr algn="ctr"/>
+              <a:r>
+                <a:rPr lang="en-US" dirty="0">
+                  <a:solidFill>
+                    <a:schemeClr val="bg2">
+                      <a:lumMod val="25000"/>
+                    </a:schemeClr>
+                  </a:solidFill>
+                </a:rPr>
+                <a:t>Distributed Query Engine</a:t>
+              </a:r>
+            </a:p>
+          </p:txBody>
+        </p:sp>
+        <p:pic>
+          <p:nvPicPr>
+            <p:cNvPr id="2" name="Imagem 1" descr="1,000+ Free User &amp; Avatar Images - Pixabay">
+              <a:extLst>
+                <a:ext uri="{FF2B5EF4-FFF2-40B4-BE49-F238E27FC236}">
+                  <a16:creationId xmlns:a16="http://schemas.microsoft.com/office/drawing/2014/main" id="{A934420F-E748-9D59-40C5-9F8CED62814D}"/>
+                </a:ext>
+              </a:extLst>
+            </p:cNvPr>
+            <p:cNvPicPr>
+              <a:picLocks noChangeAspect="1"/>
+            </p:cNvPicPr>
+            <p:nvPr/>
+          </p:nvPicPr>
+          <p:blipFill>
+            <a:blip r:embed="rId2"/>
+            <a:stretch>
+              <a:fillRect/>
+            </a:stretch>
+          </p:blipFill>
+          <p:spPr>
+            <a:xfrm>
+              <a:off x="4271751" y="929250"/>
+              <a:ext cx="1064525" cy="1001906"/>
+            </a:xfrm>
+            <a:prstGeom prst="rect">
+              <a:avLst/>
+            </a:prstGeom>
+          </p:spPr>
+        </p:pic>
+        <p:pic>
+          <p:nvPicPr>
+            <p:cNvPr id="3" name="Imagem 2" descr="Sistema - ícones de computador grátis">
+              <a:extLst>
+                <a:ext uri="{FF2B5EF4-FFF2-40B4-BE49-F238E27FC236}">
+                  <a16:creationId xmlns:a16="http://schemas.microsoft.com/office/drawing/2014/main" id="{FB7D15D4-4E74-25FD-3755-C24BEB1F62EF}"/>
+                </a:ext>
+              </a:extLst>
+            </p:cNvPr>
+            <p:cNvPicPr>
+              <a:picLocks noChangeAspect="1"/>
+            </p:cNvPicPr>
+            <p:nvPr/>
+          </p:nvPicPr>
+          <p:blipFill>
+            <a:blip r:embed="rId3"/>
+            <a:stretch>
+              <a:fillRect/>
+            </a:stretch>
+          </p:blipFill>
+          <p:spPr>
+            <a:xfrm>
+              <a:off x="2183640" y="866631"/>
+              <a:ext cx="1064525" cy="1064525"/>
+            </a:xfrm>
+            <a:prstGeom prst="rect">
+              <a:avLst/>
+            </a:prstGeom>
+          </p:spPr>
+        </p:pic>
+        <p:sp>
+          <p:nvSpPr>
+            <p:cNvPr id="4" name="Retângulo: Cantos Arredondados 3">
+              <a:extLst>
+                <a:ext uri="{FF2B5EF4-FFF2-40B4-BE49-F238E27FC236}">
+                  <a16:creationId xmlns:a16="http://schemas.microsoft.com/office/drawing/2014/main" id="{BD4507A6-3487-563C-A391-EABB3267B46D}"/>
+                </a:ext>
+              </a:extLst>
+            </p:cNvPr>
+            <p:cNvSpPr/>
+            <p:nvPr/>
+          </p:nvSpPr>
+          <p:spPr>
+            <a:xfrm>
+              <a:off x="2702256" y="2719316"/>
+              <a:ext cx="1978926" cy="887104"/>
+            </a:xfrm>
+            <a:prstGeom prst="roundRect">
+              <a:avLst/>
+            </a:prstGeom>
+            <a:solidFill>
+              <a:schemeClr val="bg1">
+                <a:lumMod val="95000"/>
+              </a:schemeClr>
+            </a:solidFill>
+            <a:ln>
+              <a:solidFill>
+                <a:schemeClr val="bg1">
+                  <a:lumMod val="75000"/>
+                </a:schemeClr>
+              </a:solidFill>
+            </a:ln>
+          </p:spPr>
+          <p:style>
+            <a:lnRef idx="2">
+              <a:schemeClr val="accent1">
+                <a:shade val="15000"/>
+              </a:schemeClr>
+            </a:lnRef>
+            <a:fillRef idx="1">
+              <a:schemeClr val="accent1"/>
+            </a:fillRef>
+            <a:effectRef idx="0">
+              <a:schemeClr val="accent1"/>
+            </a:effectRef>
+            <a:fontRef idx="minor">
+              <a:schemeClr val="lt1"/>
+            </a:fontRef>
+          </p:style>
+          <p:txBody>
+            <a:bodyPr rtlCol="0" anchor="ctr"/>
+            <a:lstStyle/>
+            <a:p>
+              <a:pPr algn="ctr"/>
+              <a:r>
+                <a:rPr lang="en-US" dirty="0">
+                  <a:solidFill>
+                    <a:schemeClr val="bg2">
+                      <a:lumMod val="25000"/>
+                    </a:schemeClr>
+                  </a:solidFill>
+                </a:rPr>
+                <a:t>Provenance Annotator</a:t>
+              </a:r>
+            </a:p>
+          </p:txBody>
+        </p:sp>
+        <p:grpSp>
+          <p:nvGrpSpPr>
+            <p:cNvPr id="13" name="Agrupar 12">
+              <a:extLst>
+                <a:ext uri="{FF2B5EF4-FFF2-40B4-BE49-F238E27FC236}">
+                  <a16:creationId xmlns:a16="http://schemas.microsoft.com/office/drawing/2014/main" id="{7A7AAF82-7AAB-15FC-55E6-C9AFC38CAA5C}"/>
+                </a:ext>
+              </a:extLst>
+            </p:cNvPr>
+            <p:cNvGrpSpPr/>
+            <p:nvPr/>
+          </p:nvGrpSpPr>
+          <p:grpSpPr>
+            <a:xfrm>
+              <a:off x="1065984" y="6250674"/>
+              <a:ext cx="5319708" cy="920600"/>
+              <a:chOff x="385056" y="6141492"/>
+              <a:chExt cx="6782294" cy="1173707"/>
+            </a:xfrm>
+          </p:grpSpPr>
+          <p:pic>
+            <p:nvPicPr>
+              <p:cNvPr id="7" name="Imagem 6">
+                <a:extLst>
+                  <a:ext uri="{FF2B5EF4-FFF2-40B4-BE49-F238E27FC236}">
+                    <a16:creationId xmlns:a16="http://schemas.microsoft.com/office/drawing/2014/main" id="{2C8A9CE9-89E1-533B-B51D-D3B3E86701EB}"/>
+                  </a:ext>
+                </a:extLst>
+              </p:cNvPr>
+              <p:cNvPicPr>
+                <a:picLocks noChangeAspect="1"/>
+              </p:cNvPicPr>
+              <p:nvPr/>
+            </p:nvPicPr>
+            <p:blipFill>
+              <a:blip r:embed="rId4"/>
+              <a:stretch>
+                <a:fillRect/>
+              </a:stretch>
+            </p:blipFill>
+            <p:spPr>
+              <a:xfrm>
+                <a:off x="1456406" y="6141492"/>
+                <a:ext cx="4639594" cy="1173707"/>
+              </a:xfrm>
+              <a:prstGeom prst="rect">
+                <a:avLst/>
+              </a:prstGeom>
+            </p:spPr>
+          </p:pic>
+          <p:pic>
+            <p:nvPicPr>
+              <p:cNvPr id="9" name="Imagem 8" descr="sample json file download">
+                <a:extLst>
+                  <a:ext uri="{FF2B5EF4-FFF2-40B4-BE49-F238E27FC236}">
+                    <a16:creationId xmlns:a16="http://schemas.microsoft.com/office/drawing/2014/main" id="{386C9DB5-6D05-617A-2086-9DCE3443FFA4}"/>
+                  </a:ext>
+                </a:extLst>
+              </p:cNvPr>
+              <p:cNvPicPr>
+                <a:picLocks noChangeAspect="1"/>
+              </p:cNvPicPr>
+              <p:nvPr/>
+            </p:nvPicPr>
+            <p:blipFill>
+              <a:blip r:embed="rId5"/>
+              <a:stretch>
+                <a:fillRect/>
+              </a:stretch>
+            </p:blipFill>
+            <p:spPr>
+              <a:xfrm>
+                <a:off x="6096000" y="6243849"/>
+                <a:ext cx="1071350" cy="1071350"/>
+              </a:xfrm>
+              <a:prstGeom prst="rect">
+                <a:avLst/>
+              </a:prstGeom>
+            </p:spPr>
+          </p:pic>
+          <p:pic>
+            <p:nvPicPr>
+              <p:cNvPr id="11" name="Imagem 10" descr="Api Icons and Symbols - Download Free PNG &amp; SVG">
+                <a:extLst>
+                  <a:ext uri="{FF2B5EF4-FFF2-40B4-BE49-F238E27FC236}">
+                    <a16:creationId xmlns:a16="http://schemas.microsoft.com/office/drawing/2014/main" id="{D7858331-DEED-96AC-48E3-7FC9F39D5378}"/>
+                  </a:ext>
+                </a:extLst>
+              </p:cNvPr>
+              <p:cNvPicPr>
+                <a:picLocks noChangeAspect="1"/>
+              </p:cNvPicPr>
+              <p:nvPr/>
+            </p:nvPicPr>
+            <p:blipFill>
+              <a:blip r:embed="rId6"/>
+              <a:stretch>
+                <a:fillRect/>
+              </a:stretch>
+            </p:blipFill>
+            <p:spPr>
+              <a:xfrm>
+                <a:off x="385056" y="6243849"/>
+                <a:ext cx="1071350" cy="1071350"/>
+              </a:xfrm>
+              <a:prstGeom prst="rect">
+                <a:avLst/>
+              </a:prstGeom>
+            </p:spPr>
+          </p:pic>
+        </p:grpSp>
+        <p:cxnSp>
+          <p:nvCxnSpPr>
+            <p:cNvPr id="20" name="Conexão reta unidirecional 19">
+              <a:extLst>
+                <a:ext uri="{FF2B5EF4-FFF2-40B4-BE49-F238E27FC236}">
+                  <a16:creationId xmlns:a16="http://schemas.microsoft.com/office/drawing/2014/main" id="{812BA641-CBAD-2743-E8A0-6EEE3B088E9B}"/>
+                </a:ext>
+              </a:extLst>
+            </p:cNvPr>
+            <p:cNvCxnSpPr>
+              <a:stCxn id="4" idx="2"/>
+              <a:endCxn id="5" idx="0"/>
+            </p:cNvCxnSpPr>
+            <p:nvPr/>
+          </p:nvCxnSpPr>
+          <p:spPr>
+            <a:xfrm>
+              <a:off x="3691719" y="3606420"/>
+              <a:ext cx="0" cy="783040"/>
+            </a:xfrm>
+            <a:prstGeom prst="straightConnector1">
+              <a:avLst/>
+            </a:prstGeom>
+            <a:ln>
+              <a:headEnd type="triangle"/>
+              <a:tailEnd type="triangle"/>
+            </a:ln>
+          </p:spPr>
+          <p:style>
+            <a:lnRef idx="2">
+              <a:schemeClr val="accent1"/>
+            </a:lnRef>
+            <a:fillRef idx="0">
+              <a:schemeClr val="accent1"/>
+            </a:fillRef>
+            <a:effectRef idx="1">
+              <a:schemeClr val="accent1"/>
+            </a:effectRef>
+            <a:fontRef idx="minor">
+              <a:schemeClr val="tx1"/>
+            </a:fontRef>
+          </p:style>
+        </p:cxnSp>
+        <p:cxnSp>
+          <p:nvCxnSpPr>
+            <p:cNvPr id="21" name="Conexão reta unidirecional 20">
+              <a:extLst>
+                <a:ext uri="{FF2B5EF4-FFF2-40B4-BE49-F238E27FC236}">
+                  <a16:creationId xmlns:a16="http://schemas.microsoft.com/office/drawing/2014/main" id="{DB86E2D3-B267-B5D9-6127-A40440BD15BD}"/>
+                </a:ext>
+              </a:extLst>
+            </p:cNvPr>
+            <p:cNvCxnSpPr>
+              <a:cxnSpLocks/>
+              <a:stCxn id="2" idx="2"/>
+            </p:cNvCxnSpPr>
+            <p:nvPr/>
+          </p:nvCxnSpPr>
+          <p:spPr>
+            <a:xfrm flipH="1">
+              <a:off x="3828198" y="1931156"/>
+              <a:ext cx="975816" cy="783040"/>
+            </a:xfrm>
+            <a:prstGeom prst="straightConnector1">
+              <a:avLst/>
+            </a:prstGeom>
+            <a:ln>
+              <a:headEnd type="triangle"/>
+              <a:tailEnd type="triangle"/>
+            </a:ln>
+          </p:spPr>
+          <p:style>
+            <a:lnRef idx="2">
+              <a:schemeClr val="accent1"/>
+            </a:lnRef>
+            <a:fillRef idx="0">
+              <a:schemeClr val="accent1"/>
+            </a:fillRef>
+            <a:effectRef idx="1">
+              <a:schemeClr val="accent1"/>
+            </a:effectRef>
+            <a:fontRef idx="minor">
+              <a:schemeClr val="tx1"/>
+            </a:fontRef>
+          </p:style>
+        </p:cxnSp>
+        <p:cxnSp>
+          <p:nvCxnSpPr>
+            <p:cNvPr id="24" name="Conexão reta unidirecional 23">
+              <a:extLst>
+                <a:ext uri="{FF2B5EF4-FFF2-40B4-BE49-F238E27FC236}">
+                  <a16:creationId xmlns:a16="http://schemas.microsoft.com/office/drawing/2014/main" id="{86297FDF-2212-9DD7-B87E-3C9DA0BF2D8E}"/>
+                </a:ext>
+              </a:extLst>
+            </p:cNvPr>
+            <p:cNvCxnSpPr>
+              <a:cxnSpLocks/>
+              <a:stCxn id="3" idx="2"/>
+            </p:cNvCxnSpPr>
+            <p:nvPr/>
+          </p:nvCxnSpPr>
+          <p:spPr>
+            <a:xfrm>
+              <a:off x="2715903" y="1931156"/>
+              <a:ext cx="846163" cy="783040"/>
+            </a:xfrm>
+            <a:prstGeom prst="straightConnector1">
+              <a:avLst/>
+            </a:prstGeom>
+            <a:ln>
+              <a:headEnd type="triangle"/>
+              <a:tailEnd type="triangle"/>
+            </a:ln>
+          </p:spPr>
+          <p:style>
+            <a:lnRef idx="2">
+              <a:schemeClr val="accent1"/>
+            </a:lnRef>
+            <a:fillRef idx="0">
+              <a:schemeClr val="accent1"/>
+            </a:fillRef>
+            <a:effectRef idx="1">
+              <a:schemeClr val="accent1"/>
+            </a:effectRef>
+            <a:fontRef idx="minor">
+              <a:schemeClr val="tx1"/>
+            </a:fontRef>
+          </p:style>
+        </p:cxnSp>
+      </p:grpSp>
+    </p:spTree>
+    <p:extLst>
+      <p:ext uri="{BB962C8B-B14F-4D97-AF65-F5344CB8AC3E}">
+        <p14:creationId xmlns:p14="http://schemas.microsoft.com/office/powerpoint/2010/main" val="1676960890"/>
+      </p:ext>
+    </p:extLst>
+  </p:cSld>
+  <p:clrMapOvr>
+    <a:masterClrMapping/>
+  </p:clrMapOvr>
+</p:sld>
+</file>
+
 <file path=ppt/theme/theme1.xml><?xml version="1.0" encoding="utf-8"?>
 <a:theme xmlns:a="http://schemas.openxmlformats.org/drawingml/2006/main" name="Tema do Office">
   <a:themeElements>

</xml_diff>